<commit_message>
Docs: Modify the manual about project settings
- project_setting__developement_environment.pptx were minor-changed
</commit_message>
<xml_diff>
--- a/cpp/doc/project_setting__developement_environment.pptx
+++ b/cpp/doc/project_setting__developement_environment.pptx
@@ -262,7 +262,7 @@
             <a:fld id="{7A1B90C6-478F-4020-94F7-7A365D69A3A0}" type="datetimeFigureOut">
               <a:rPr lang="ko-KR" altLang="en-US" smtClean="0"/>
               <a:pPr/>
-              <a:t>2024-11-05</a:t>
+              <a:t>2024-11-07</a:t>
             </a:fld>
             <a:endParaRPr lang="ko-KR" altLang="en-US"/>
           </a:p>
@@ -424,7 +424,7 @@
             <a:fld id="{B21C34AF-9FD1-4FB2-A2EC-FD937BF46C9F}" type="datetimeFigureOut">
               <a:rPr lang="ko-KR" altLang="en-US" smtClean="0"/>
               <a:pPr/>
-              <a:t>2024-11-05</a:t>
+              <a:t>2024-11-07</a:t>
             </a:fld>
             <a:endParaRPr lang="ko-KR" altLang="en-US"/>
           </a:p>
@@ -4602,7 +4602,7 @@
           <a:graphicData uri="http://schemas.openxmlformats.org/presentationml/2006/ole">
             <mc:AlternateContent xmlns:mc="http://schemas.openxmlformats.org/markup-compatibility/2006">
               <mc:Choice xmlns:v="urn:schemas-microsoft-com:vml" Requires="v">
-                <p:oleObj spid="_x0000_s1248" name="Image" r:id="rId15" imgW="5600000" imgH="1117460" progId="">
+                <p:oleObj spid="_x0000_s1252" name="Image" r:id="rId15" imgW="5600000" imgH="1117460" progId="">
                   <p:embed/>
                 </p:oleObj>
               </mc:Choice>
@@ -5474,7 +5474,7 @@
           <a:p>
             <a:r>
               <a:rPr lang="en-US" altLang="ko-KR" dirty="0" smtClean="0"/>
-              <a:t>Environment</a:t>
+              <a:t>Toolchain</a:t>
             </a:r>
             <a:endParaRPr lang="ko-KR" altLang="en-US" dirty="0"/>
           </a:p>
@@ -5499,6 +5499,40 @@
           <a:p>
             <a:r>
               <a:rPr lang="en-US" altLang="ko-KR" dirty="0" smtClean="0"/>
+              <a:t>Compiler</a:t>
+            </a:r>
+            <a:endParaRPr lang="en-US" altLang="ko-KR" dirty="0" smtClean="0"/>
+          </a:p>
+          <a:p>
+            <a:pPr lvl="1"/>
+            <a:r>
+              <a:rPr lang="en-US" altLang="ko-KR" dirty="0" smtClean="0"/>
+              <a:t>C/C++ Compiler</a:t>
+            </a:r>
+          </a:p>
+          <a:p>
+            <a:pPr lvl="2"/>
+            <a:r>
+              <a:rPr lang="en-US" altLang="ko-KR" dirty="0" smtClean="0"/>
+              <a:t>Microsoft Visual C++ 8</a:t>
+            </a:r>
+          </a:p>
+          <a:p>
+            <a:r>
+              <a:rPr lang="en-US" altLang="ko-KR" dirty="0" smtClean="0"/>
+              <a:t>IDE</a:t>
+            </a:r>
+          </a:p>
+          <a:p>
+            <a:pPr lvl="1"/>
+            <a:r>
+              <a:rPr lang="en-US" altLang="ko-KR" dirty="0" smtClean="0"/>
+              <a:t>Visual Studio 2005</a:t>
+            </a:r>
+          </a:p>
+          <a:p>
+            <a:r>
+              <a:rPr lang="en-US" altLang="ko-KR" dirty="0" smtClean="0"/>
               <a:t>OS</a:t>
             </a:r>
           </a:p>
@@ -5515,40 +5549,7 @@
               <a:rPr lang="en-US" altLang="ko-KR" dirty="0" smtClean="0"/>
               <a:t>Service Pack 3</a:t>
             </a:r>
-          </a:p>
-          <a:p>
-            <a:r>
-              <a:rPr lang="en-US" altLang="ko-KR" dirty="0" smtClean="0"/>
-              <a:t>Compiler</a:t>
-            </a:r>
-          </a:p>
-          <a:p>
-            <a:pPr lvl="1"/>
-            <a:r>
-              <a:rPr lang="en-US" altLang="ko-KR" dirty="0" smtClean="0"/>
-              <a:t>C/C++ Compiler</a:t>
-            </a:r>
-          </a:p>
-          <a:p>
-            <a:pPr lvl="2"/>
-            <a:r>
-              <a:rPr lang="en-US" altLang="ko-KR" dirty="0" smtClean="0"/>
-              <a:t>Microsoft Visual C++ 8</a:t>
-            </a:r>
-          </a:p>
-          <a:p>
-            <a:pPr lvl="1"/>
-            <a:r>
-              <a:rPr lang="en-US" altLang="ko-KR" dirty="0" smtClean="0"/>
-              <a:t>IDE</a:t>
-            </a:r>
-          </a:p>
-          <a:p>
-            <a:pPr lvl="2"/>
-            <a:r>
-              <a:rPr lang="en-US" altLang="ko-KR" dirty="0" smtClean="0"/>
-              <a:t>Visual Studio 2005</a:t>
-            </a:r>
+            <a:endParaRPr lang="en-US" altLang="ko-KR" dirty="0" smtClean="0"/>
           </a:p>
         </p:txBody>
       </p:sp>
@@ -5593,8 +5594,12 @@
           <a:lstStyle/>
           <a:p>
             <a:r>
+              <a:rPr lang="en-US" altLang="ko-KR" dirty="0"/>
+              <a:t>Version Control </a:t>
+            </a:r>
+            <a:r>
               <a:rPr lang="en-US" altLang="ko-KR" dirty="0" smtClean="0"/>
-              <a:t>Environment</a:t>
+              <a:t>System</a:t>
             </a:r>
             <a:endParaRPr lang="ko-KR" altLang="en-US" dirty="0"/>
           </a:p>
@@ -5619,25 +5624,19 @@
           <a:p>
             <a:r>
               <a:rPr lang="en-US" altLang="ko-KR" dirty="0" smtClean="0"/>
-              <a:t>Version Control System</a:t>
-            </a:r>
+              <a:t>Subversion</a:t>
+            </a:r>
+            <a:endParaRPr lang="en-US" altLang="ko-KR" dirty="0" smtClean="0"/>
           </a:p>
           <a:p>
             <a:pPr lvl="1"/>
-            <a:r>
-              <a:rPr lang="en-US" altLang="ko-KR" dirty="0" smtClean="0"/>
-              <a:t>Subversion</a:t>
-            </a:r>
-          </a:p>
-          <a:p>
-            <a:pPr lvl="2"/>
             <a:r>
               <a:rPr lang="en-US" altLang="ko-KR" dirty="0" smtClean="0"/>
               <a:t>Server</a:t>
             </a:r>
           </a:p>
           <a:p>
-            <a:pPr lvl="3"/>
+            <a:pPr lvl="2"/>
             <a:r>
               <a:rPr lang="en-US" altLang="ko-KR" dirty="0" smtClean="0">
                 <a:hlinkClick r:id="rId3"/>
@@ -5647,14 +5646,14 @@
             <a:endParaRPr lang="en-US" altLang="ko-KR" dirty="0" smtClean="0"/>
           </a:p>
           <a:p>
-            <a:pPr lvl="2"/>
+            <a:pPr lvl="1"/>
             <a:r>
               <a:rPr lang="en-US" altLang="ko-KR" dirty="0" smtClean="0"/>
               <a:t>Client</a:t>
             </a:r>
           </a:p>
           <a:p>
-            <a:pPr lvl="3"/>
+            <a:pPr lvl="2"/>
             <a:r>
               <a:rPr lang="en-US" altLang="ko-KR" dirty="0" err="1" smtClean="0"/>
               <a:t>TortoiseSVN</a:t>
@@ -5662,7 +5661,7 @@
             <a:endParaRPr lang="en-US" altLang="ko-KR" dirty="0" smtClean="0"/>
           </a:p>
           <a:p>
-            <a:pPr lvl="3"/>
+            <a:pPr lvl="2"/>
             <a:r>
               <a:rPr lang="en-US" altLang="ko-KR" dirty="0" smtClean="0">
                 <a:hlinkClick r:id="rId4"/>
@@ -5672,7 +5671,7 @@
             <a:endParaRPr lang="en-US" altLang="ko-KR" dirty="0" smtClean="0"/>
           </a:p>
           <a:p>
-            <a:pPr lvl="2"/>
+            <a:pPr lvl="1"/>
             <a:r>
               <a:rPr lang="en-US" altLang="ko-KR" dirty="0" smtClean="0"/>
               <a:t>Web Browser</a:t>
@@ -5684,7 +5683,7 @@
             <a:endParaRPr lang="en-US" altLang="ko-KR" dirty="0" smtClean="0"/>
           </a:p>
           <a:p>
-            <a:pPr lvl="3"/>
+            <a:pPr lvl="2"/>
             <a:r>
               <a:rPr lang="en-US" altLang="ko-KR" dirty="0" smtClean="0"/>
               <a:t>Subversion repository URL</a:t>
@@ -5712,7 +5711,7 @@
             <a:endParaRPr lang="en-US" altLang="ko-KR" dirty="0" smtClean="0"/>
           </a:p>
           <a:p>
-            <a:pPr lvl="4"/>
+            <a:pPr lvl="3"/>
             <a:r>
               <a:rPr lang="ko-KR" altLang="en-US" dirty="0" smtClean="0"/>
               <a:t>단</a:t>
@@ -5728,7 +5727,7 @@
             <a:endParaRPr lang="en-US" altLang="ko-KR" dirty="0" smtClean="0"/>
           </a:p>
           <a:p>
-            <a:pPr lvl="3"/>
+            <a:pPr lvl="2"/>
             <a:r>
               <a:rPr lang="en-US" altLang="ko-KR" dirty="0" smtClean="0"/>
               <a:t>SSL</a:t>
@@ -6310,8 +6309,16 @@
               <a:t>rd</a:t>
             </a:r>
             <a:r>
+              <a:rPr lang="en-US" altLang="ko-KR" dirty="0"/>
+              <a:t>-</a:t>
+            </a:r>
+            <a:r>
               <a:rPr lang="en-US" altLang="ko-KR" dirty="0" smtClean="0"/>
-              <a:t> Party Library</a:t>
+              <a:t>Party </a:t>
+            </a:r>
+            <a:r>
+              <a:rPr lang="en-US" altLang="ko-KR" dirty="0" smtClean="0"/>
+              <a:t>Library</a:t>
             </a:r>
             <a:endParaRPr lang="ko-KR" altLang="en-US" dirty="0"/>
           </a:p>
@@ -6376,28 +6383,19 @@
             <a:pPr lvl="2"/>
             <a:r>
               <a:rPr lang="en-US" altLang="ko-KR" dirty="0" smtClean="0"/>
-              <a:t>${</a:t>
+              <a:t>${SWL_REPO}/</a:t>
             </a:r>
             <a:r>
               <a:rPr lang="en-US" altLang="ko-KR" dirty="0" smtClean="0"/>
-              <a:t>SWL_REPO}/</a:t>
-            </a:r>
-            <a:r>
-              <a:rPr lang="en-US" altLang="ko-KR" dirty="0" smtClean="0"/>
-              <a:t>3rd</a:t>
-            </a:r>
-            <a:r>
-              <a:rPr lang="en-US" altLang="ko-KR" dirty="0" smtClean="0"/>
-              <a:t>/include/</a:t>
-            </a:r>
-            <a:r>
-              <a:rPr lang="en-US" altLang="ko-KR" dirty="0" smtClean="0"/>
-              <a:t>boost </a:t>
-            </a:r>
+              <a:t>3rd/include/boost</a:t>
+            </a:r>
+          </a:p>
+          <a:p>
             <a:r>
               <a:rPr lang="en-US" altLang="ko-KR" dirty="0" smtClean="0"/>
               <a:t>OpenCV</a:t>
             </a:r>
+            <a:endParaRPr lang="en-US" altLang="ko-KR" dirty="0" smtClean="0"/>
           </a:p>
           <a:p>
             <a:pPr lvl="1"/>
@@ -6444,15 +6442,7 @@
             <a:pPr lvl="2"/>
             <a:r>
               <a:rPr lang="en-US" altLang="ko-KR" dirty="0" smtClean="0"/>
-              <a:t>${</a:t>
-            </a:r>
-            <a:r>
-              <a:rPr lang="en-US" altLang="ko-KR" dirty="0" smtClean="0"/>
-              <a:t>SWL_REPO}/</a:t>
-            </a:r>
-            <a:r>
-              <a:rPr lang="en-US" altLang="ko-KR" dirty="0" smtClean="0"/>
-              <a:t>3rd/include/</a:t>
+              <a:t>${SWL_REPO}/3rd/include/</a:t>
             </a:r>
             <a:r>
               <a:rPr lang="en-US" altLang="ko-KR" dirty="0" err="1" smtClean="0"/>
@@ -6500,20 +6490,8 @@
           <a:p>
             <a:pPr lvl="2"/>
             <a:r>
-              <a:rPr lang="en-US" altLang="ko-KR" smtClean="0"/>
-              <a:t>${</a:t>
-            </a:r>
-            <a:r>
               <a:rPr lang="en-US" altLang="ko-KR" dirty="0" smtClean="0"/>
-              <a:t>SWL_REPO}/</a:t>
-            </a:r>
-            <a:r>
-              <a:rPr lang="en-US" altLang="ko-KR" dirty="0" smtClean="0"/>
-              <a:t>3rd</a:t>
-            </a:r>
-            <a:r>
-              <a:rPr lang="en-US" altLang="ko-KR" dirty="0" smtClean="0"/>
-              <a:t>/include/</a:t>
+              <a:t>${SWL_REPO}/3rd/include/</a:t>
             </a:r>
             <a:r>
               <a:rPr lang="en-US" altLang="ko-KR" dirty="0" err="1" smtClean="0"/>

</xml_diff>